<commit_message>
Troca Energy Spin por ESP na apresentação
Co-Authored-By: Claude Opus 5.5 <noreply@anthropic.com>
Claude-Session: https://claude.ai/code/session_01Kg8HJBfGo9nn3yWWi5ce7m
</commit_message>
<xml_diff>
--- a/docs/ZeroInvest_Apresentacao_Investidores.pptx
+++ b/docs/ZeroInvest_Apresentacao_Investidores.pptx
@@ -117,33 +117,33 @@
   <p:extLst>
     <p:ext uri="{521415D9-36F7-43E2-AB2F-B90AF26B5E84}">
       <p14:sectionLst xmlns:p14="http://schemas.microsoft.com/office/powerpoint/2010/main">
-        <p14:section name="Abertura" id="{0fb7f062-1fa0-0577-7b9a-caabab2ff861}">
+        <p14:section name="Abertura" id="{eacc1b23-2c1f-bd3d-7ec6-c3adb2f335ac}">
           <p14:sldIdLst>
             <p14:sldId id="256"/>
           </p14:sldIdLst>
         </p14:section>
-        <p14:section name="Tese" id="{c60cf77e-5536-1820-e0b1-ba3cc0e13f24}">
+        <p14:section name="Tese" id="{5c2da1f0-c2cf-e1ef-ad30-a54bd1c90490}">
           <p14:sldIdLst>
             <p14:sldId id="257"/>
             <p14:sldId id="258"/>
             <p14:sldId id="259"/>
           </p14:sldIdLst>
         </p14:section>
-        <p14:section name="Estrutura" id="{f5e960be-47e3-9ee8-d48c-c8017ce6d512}">
+        <p14:section name="Estrutura" id="{c30da117-608d-5e0e-5fd6-3ee24d6a8a6a}">
           <p14:sldIdLst>
             <p14:sldId id="260"/>
             <p14:sldId id="261"/>
             <p14:sldId id="262"/>
           </p14:sldIdLst>
         </p14:section>
-        <p14:section name="Escala" id="{ca3b64ee-06c3-ea4c-b004-9a71ab8b4fd6}">
+        <p14:section name="Escala" id="{d847d35c-cade-c58c-e743-5675f70da8d8}">
           <p14:sldIdLst>
             <p14:sldId id="263"/>
             <p14:sldId id="264"/>
             <p14:sldId id="265"/>
           </p14:sldIdLst>
         </p14:section>
-        <p14:section name="Próximos passos" id="{5efd8ec6-f887-a76d-d3a3-abd40998b183}">
+        <p14:section name="Próximos passos" id="{61ae066c-abab-99a2-82d0-0d83f9f25433}">
           <p14:sldIdLst>
             <p14:sldId id="266"/>
           </p14:sldIdLst>
@@ -1122,7 +1122,7 @@
               <a:rPr lang="en-US" dirty="0"/>
               <a:t>Métricas internas de tração. Usar como prova de validação, sem projetar crescimento não aprovado.
 [Sources]
-- Dados internos Gorila Energy / Energy Spin, base informada pelo usuário.
+- Dados internos Gorila Energy / ESP, base informada pelo usuário.
 [/Sources]</a:t>
             </a:r>
             <a:endParaRPr lang="en-US" dirty="0"/>
@@ -1393,7 +1393,7 @@
           <a:p>
             <a:r>
               <a:rPr lang="en-US" dirty="0"/>
-              <a:t>Reforçar a distinção pedida pelo usuário: Gorila Energy é a marca; Energy Spin é a empresa responsável pela operação.
+              <a:t>Reforçar a distinção pedida pelo usuário: Gorila Energy é a marca; ESP é a empresa responsável pela operação.
 [Sources]
 - Arquitetura de marca e operação fornecida pelo usuário.
 - Manual e logos oficiais Gorila Energy fornecidos pelo usuário.
@@ -1672,7 +1672,7 @@
               <a:t>A mensagem combina capacidade de mobilização nacional, histórico executivo dos sócios e acesso comercial qualificado a condomínios.
 [Sources]
 - Históricos profissionais do arquivo socios.pptx fornecido pelo usuário.
-- Arquitetura operacional Gorila Energy / Energy Spin fornecida pelo usuário.
+- Arquitetura operacional Gorila Energy / ESP fornecida pelo usuário.
 - Parceria com a Lello e carteira de 4.500 prédios informadas pelo usuário.
 [/Sources]</a:t>
             </a:r>
@@ -1893,7 +1893,7 @@
                   <a:schemeClr val="accent3"/>
                 </a:solidFill>
               </a:rPr>
-              <a:t>ZERO INVEST  •  GORILA ENERGY  •  OPERAÇÃO ENERGY SPIN</a:t>
+              <a:t>ZERO INVEST  •  GORILA ENERGY  •  OPERAÇÃO ESP</a:t>
             </a:r>
             <a:endParaRPr lang="en-US" sz="900" dirty="0"/>
           </a:p>
@@ -2084,7 +2084,7 @@
                   <a:schemeClr val="accent2"/>
                 </a:solidFill>
               </a:rPr>
-              <a:t>ZERO INVEST  •  GORILA ENERGY  •  OPERAÇÃO ENERGY SPIN</a:t>
+              <a:t>ZERO INVEST  •  GORILA ENERGY  •  OPERAÇÃO ESP</a:t>
             </a:r>
             <a:endParaRPr lang="en-US" sz="900" dirty="0"/>
           </a:p>
@@ -3093,7 +3093,7 @@
                   <a:schemeClr val="accent1"/>
                 </a:solidFill>
               </a:rPr>
-              <a:t>GORILA ENERGY  •  OPERAÇÃO ENERGY SPIN</a:t>
+              <a:t>GORILA ENERGY  •  OPERAÇÃO ESP</a:t>
             </a:r>
             <a:endParaRPr lang="en-US" sz="1000" dirty="0"/>
           </a:p>
@@ -7440,7 +7440,7 @@
                   <a:schemeClr val="tx2"/>
                 </a:solidFill>
               </a:rPr>
-              <a:t>Gorila Energy abre o mercado. Energy Spin entrega a operação.</a:t>
+              <a:t>Gorila Energy abre o mercado. ESP entrega a operação.</a:t>
             </a:r>
             <a:endParaRPr lang="en-US" sz="2800" dirty="0"/>
           </a:p>
@@ -7837,7 +7837,7 @@
                 <a:ea typeface="Arial" pitchFamily="34" charset="-122"/>
                 <a:cs typeface="Arial" pitchFamily="34" charset="-120"/>
               </a:rPr>
-              <a:t>ENERGY SPIN</a:t>
+              <a:t>ESP</a:t>
             </a:r>
             <a:endParaRPr lang="en-US" sz="2600" dirty="0"/>
           </a:p>

</xml_diff>

<commit_message>
Slide de tração: adiciona R$ 100 mil em dividendos e atualiza captação e ativos
Co-Authored-By: Claude Opus 5.5 <noreply@anthropic.com>
Claude-Session: https://claude.ai/code/session_01Kg8HJBfGo9nn3yWWi5ce7m
</commit_message>
<xml_diff>
--- a/docs/ZeroInvest_Apresentacao_Investidores.pptx
+++ b/docs/ZeroInvest_Apresentacao_Investidores.pptx
@@ -117,33 +117,33 @@
   <p:extLst>
     <p:ext uri="{521415D9-36F7-43E2-AB2F-B90AF26B5E84}">
       <p14:sectionLst xmlns:p14="http://schemas.microsoft.com/office/powerpoint/2010/main">
-        <p14:section name="Abertura" id="{eacc1b23-2c1f-bd3d-7ec6-c3adb2f335ac}">
+        <p14:section name="Abertura" id="{090b2835-78ec-639f-6740-d3d278cc3403}">
           <p14:sldIdLst>
             <p14:sldId id="256"/>
           </p14:sldIdLst>
         </p14:section>
-        <p14:section name="Tese" id="{5c2da1f0-c2cf-e1ef-ad30-a54bd1c90490}">
+        <p14:section name="Tese" id="{b7105860-1d14-e55e-7f3b-c759883dd2e0}">
           <p14:sldIdLst>
             <p14:sldId id="257"/>
             <p14:sldId id="258"/>
             <p14:sldId id="259"/>
           </p14:sldIdLst>
         </p14:section>
-        <p14:section name="Estrutura" id="{c30da117-608d-5e0e-5fd6-3ee24d6a8a6a}">
+        <p14:section name="Estrutura" id="{3cef878d-3b11-d803-ceca-e36668f44047}">
           <p14:sldIdLst>
             <p14:sldId id="260"/>
             <p14:sldId id="261"/>
             <p14:sldId id="262"/>
           </p14:sldIdLst>
         </p14:section>
-        <p14:section name="Escala" id="{d847d35c-cade-c58c-e743-5675f70da8d8}">
+        <p14:section name="Escala" id="{3ea90813-b0f5-e5a7-5040-a0e51e3f1646}">
           <p14:sldIdLst>
             <p14:sldId id="263"/>
             <p14:sldId id="264"/>
             <p14:sldId id="265"/>
           </p14:sldIdLst>
         </p14:section>
-        <p14:section name="Próximos passos" id="{61ae066c-abab-99a2-82d0-0d83f9f25433}">
+        <p14:section name="Próximos passos" id="{a6b32c81-482f-cac6-2be6-04fbb083ab16}">
           <p14:sldIdLst>
             <p14:sldId id="266"/>
           </p14:sldIdLst>
@@ -1120,7 +1120,7 @@
           <a:p>
             <a:r>
               <a:rPr lang="en-US" dirty="0"/>
-              <a:t>Métricas internas de tração. Usar como prova de validação, sem projetar crescimento não aprovado.
+              <a:t>Métricas internas de tração: R$ 695 mil captados, 8 ativos e R$ 100 mil em dividendos pagos aos investidores nos últimos 12 meses. Usar como prova de validação, sem projetar crescimento não aprovado.
 [Sources]
 - Dados internos Gorila Energy / ESP, base informada pelo usuário.
 [/Sources]</a:t>
@@ -4700,11 +4700,11 @@
         <p:spPr>
           <a:xfrm>
             <a:off x="548640" y="2103120"/>
-            <a:ext cx="2567864" cy="2377440"/>
+            <a:ext cx="2036003" cy="2560320"/>
           </a:xfrm>
           <a:prstGeom prst="roundRect">
             <a:avLst>
-              <a:gd name="adj" fmla="val 5769"/>
+              <a:gd name="adj" fmla="val 6737"/>
             </a:avLst>
           </a:prstGeom>
           <a:solidFill>
@@ -4721,8 +4721,8 @@
         </p:nvSpPr>
         <p:spPr>
           <a:xfrm>
-            <a:off x="822960" y="2377440"/>
-            <a:ext cx="685800" cy="685800"/>
+            <a:off x="777240" y="2331720"/>
+            <a:ext cx="640080" cy="640080"/>
           </a:xfrm>
           <a:prstGeom prst="ellipse">
             <a:avLst/>
@@ -4749,8 +4749,8 @@
         </p:blipFill>
         <p:spPr>
           <a:xfrm>
-            <a:off x="994410" y="2548890"/>
-            <a:ext cx="342900" cy="342900"/>
+            <a:off x="937260" y="2491740"/>
+            <a:ext cx="320040" cy="320040"/>
           </a:xfrm>
           <a:prstGeom prst="rect">
             <a:avLst/>
@@ -4765,8 +4765,8 @@
         </p:nvSpPr>
         <p:spPr>
           <a:xfrm>
-            <a:off x="822960" y="3246120"/>
-            <a:ext cx="2202104" cy="731520"/>
+            <a:off x="777240" y="3108960"/>
+            <a:ext cx="1715963" cy="548640"/>
           </a:xfrm>
           <a:prstGeom prst="rect">
             <a:avLst/>
@@ -4782,7 +4782,7 @@
               <a:buNone/>
             </a:pPr>
             <a:r>
-              <a:rPr lang="en-US" sz="3200" b="1" dirty="0">
+              <a:rPr lang="en-US" sz="2400" b="1" dirty="0">
                 <a:solidFill>
                   <a:schemeClr val="tx2"/>
                 </a:solidFill>
@@ -4790,9 +4790,9 @@
                 <a:ea typeface="Arial" pitchFamily="34" charset="-122"/>
                 <a:cs typeface="Arial" pitchFamily="34" charset="-120"/>
               </a:rPr>
-              <a:t>R$ 580 mil</a:t>
-            </a:r>
-            <a:endParaRPr lang="en-US" sz="3200" dirty="0"/>
+              <a:t>R$ 695 mil</a:t>
+            </a:r>
+            <a:endParaRPr lang="en-US" sz="2400" dirty="0"/>
           </a:p>
         </p:txBody>
       </p:sp>
@@ -4804,31 +4804,31 @@
         </p:nvSpPr>
         <p:spPr>
           <a:xfrm>
-            <a:off x="822960" y="3977640"/>
-            <a:ext cx="2110664" cy="320040"/>
-          </a:xfrm>
-          <a:prstGeom prst="rect">
-            <a:avLst/>
-          </a:prstGeom>
-          <a:noFill/>
-          <a:ln/>
-        </p:spPr>
-        <p:txBody>
-          <a:bodyPr wrap="square" lIns="0" tIns="0" rIns="0" bIns="0" rtlCol="0" anchor="ctr"/>
+            <a:off x="777240" y="3703320"/>
+            <a:ext cx="1624523" cy="822960"/>
+          </a:xfrm>
+          <a:prstGeom prst="rect">
+            <a:avLst/>
+          </a:prstGeom>
+          <a:noFill/>
+          <a:ln/>
+        </p:spPr>
+        <p:txBody>
+          <a:bodyPr wrap="square" lIns="0" tIns="0" rIns="0" bIns="0" rtlCol="0" anchor="t"/>
           <a:lstStyle/>
           <a:p>
             <a:pPr indent="0" marL="0">
               <a:buNone/>
             </a:pPr>
             <a:r>
-              <a:rPr lang="en-US" sz="1500" dirty="0">
+              <a:rPr lang="en-US" sz="1400" dirty="0">
                 <a:solidFill>
                   <a:srgbClr val="5B4F70"/>
                 </a:solidFill>
               </a:rPr>
               <a:t>capital captado</a:t>
             </a:r>
-            <a:endParaRPr lang="en-US" sz="1500" dirty="0"/>
+            <a:endParaRPr lang="en-US" sz="1400" dirty="0"/>
           </a:p>
         </p:txBody>
       </p:sp>
@@ -4840,12 +4840,12 @@
         </p:nvSpPr>
         <p:spPr>
           <a:xfrm>
-            <a:off x="3390824" y="2103120"/>
-            <a:ext cx="2567864" cy="2377440"/>
+            <a:off x="2813243" y="2103120"/>
+            <a:ext cx="2036003" cy="2560320"/>
           </a:xfrm>
           <a:prstGeom prst="roundRect">
             <a:avLst>
-              <a:gd name="adj" fmla="val 5769"/>
+              <a:gd name="adj" fmla="val 6737"/>
             </a:avLst>
           </a:prstGeom>
           <a:solidFill>
@@ -4862,8 +4862,8 @@
         </p:nvSpPr>
         <p:spPr>
           <a:xfrm>
-            <a:off x="3665144" y="2377440"/>
-            <a:ext cx="685800" cy="685800"/>
+            <a:off x="3041843" y="2331720"/>
+            <a:ext cx="640080" cy="640080"/>
           </a:xfrm>
           <a:prstGeom prst="ellipse">
             <a:avLst/>
@@ -4890,8 +4890,8 @@
         </p:blipFill>
         <p:spPr>
           <a:xfrm>
-            <a:off x="3836594" y="2548890"/>
-            <a:ext cx="342900" cy="342900"/>
+            <a:off x="3201863" y="2491740"/>
+            <a:ext cx="320040" cy="320040"/>
           </a:xfrm>
           <a:prstGeom prst="rect">
             <a:avLst/>
@@ -4906,8 +4906,8 @@
         </p:nvSpPr>
         <p:spPr>
           <a:xfrm>
-            <a:off x="3665144" y="3246120"/>
-            <a:ext cx="2202104" cy="731520"/>
+            <a:off x="3041843" y="3108960"/>
+            <a:ext cx="1715963" cy="548640"/>
           </a:xfrm>
           <a:prstGeom prst="rect">
             <a:avLst/>
@@ -4923,7 +4923,7 @@
               <a:buNone/>
             </a:pPr>
             <a:r>
-              <a:rPr lang="en-US" sz="3200" b="1" dirty="0">
+              <a:rPr lang="en-US" sz="2400" b="1" dirty="0">
                 <a:solidFill>
                   <a:schemeClr val="tx2"/>
                 </a:solidFill>
@@ -4931,9 +4931,9 @@
                 <a:ea typeface="Arial" pitchFamily="34" charset="-122"/>
                 <a:cs typeface="Arial" pitchFamily="34" charset="-120"/>
               </a:rPr>
-              <a:t>7</a:t>
-            </a:r>
-            <a:endParaRPr lang="en-US" sz="3200" dirty="0"/>
+              <a:t>8</a:t>
+            </a:r>
+            <a:endParaRPr lang="en-US" sz="2400" dirty="0"/>
           </a:p>
         </p:txBody>
       </p:sp>
@@ -4945,31 +4945,31 @@
         </p:nvSpPr>
         <p:spPr>
           <a:xfrm>
-            <a:off x="3665144" y="3977640"/>
-            <a:ext cx="2110664" cy="320040"/>
-          </a:xfrm>
-          <a:prstGeom prst="rect">
-            <a:avLst/>
-          </a:prstGeom>
-          <a:noFill/>
-          <a:ln/>
-        </p:spPr>
-        <p:txBody>
-          <a:bodyPr wrap="square" lIns="0" tIns="0" rIns="0" bIns="0" rtlCol="0" anchor="ctr"/>
+            <a:off x="3041843" y="3703320"/>
+            <a:ext cx="1624523" cy="822960"/>
+          </a:xfrm>
+          <a:prstGeom prst="rect">
+            <a:avLst/>
+          </a:prstGeom>
+          <a:noFill/>
+          <a:ln/>
+        </p:spPr>
+        <p:txBody>
+          <a:bodyPr wrap="square" lIns="0" tIns="0" rIns="0" bIns="0" rtlCol="0" anchor="t"/>
           <a:lstStyle/>
           <a:p>
             <a:pPr indent="0" marL="0">
               <a:buNone/>
             </a:pPr>
             <a:r>
-              <a:rPr lang="en-US" sz="1500" dirty="0">
+              <a:rPr lang="en-US" sz="1400" dirty="0">
                 <a:solidFill>
                   <a:srgbClr val="5B4F70"/>
                 </a:solidFill>
               </a:rPr>
               <a:t>ativos fotovoltaicos</a:t>
             </a:r>
-            <a:endParaRPr lang="en-US" sz="1500" dirty="0"/>
+            <a:endParaRPr lang="en-US" sz="1400" dirty="0"/>
           </a:p>
         </p:txBody>
       </p:sp>
@@ -4981,12 +4981,12 @@
         </p:nvSpPr>
         <p:spPr>
           <a:xfrm>
-            <a:off x="6233008" y="2103120"/>
-            <a:ext cx="2567864" cy="2377440"/>
+            <a:off x="5077846" y="2103120"/>
+            <a:ext cx="2036003" cy="2560320"/>
           </a:xfrm>
           <a:prstGeom prst="roundRect">
             <a:avLst>
-              <a:gd name="adj" fmla="val 5769"/>
+              <a:gd name="adj" fmla="val 6737"/>
             </a:avLst>
           </a:prstGeom>
           <a:solidFill>
@@ -5003,8 +5003,8 @@
         </p:nvSpPr>
         <p:spPr>
           <a:xfrm>
-            <a:off x="6507328" y="2377440"/>
-            <a:ext cx="685800" cy="685800"/>
+            <a:off x="5306446" y="2331720"/>
+            <a:ext cx="640080" cy="640080"/>
           </a:xfrm>
           <a:prstGeom prst="ellipse">
             <a:avLst/>
@@ -5031,8 +5031,8 @@
         </p:blipFill>
         <p:spPr>
           <a:xfrm>
-            <a:off x="6678778" y="2548890"/>
-            <a:ext cx="342900" cy="342900"/>
+            <a:off x="5466466" y="2491740"/>
+            <a:ext cx="320040" cy="320040"/>
           </a:xfrm>
           <a:prstGeom prst="rect">
             <a:avLst/>
@@ -5047,8 +5047,8 @@
         </p:nvSpPr>
         <p:spPr>
           <a:xfrm>
-            <a:off x="6507328" y="3246120"/>
-            <a:ext cx="2202104" cy="731520"/>
+            <a:off x="5306446" y="3108960"/>
+            <a:ext cx="1715963" cy="548640"/>
           </a:xfrm>
           <a:prstGeom prst="rect">
             <a:avLst/>
@@ -5064,7 +5064,7 @@
               <a:buNone/>
             </a:pPr>
             <a:r>
-              <a:rPr lang="en-US" sz="3200" b="1" dirty="0">
+              <a:rPr lang="en-US" sz="2400" b="1" dirty="0">
                 <a:solidFill>
                   <a:schemeClr val="tx2"/>
                 </a:solidFill>
@@ -5074,7 +5074,7 @@
               </a:rPr>
               <a:t>R$ 2,9 mi</a:t>
             </a:r>
-            <a:endParaRPr lang="en-US" sz="3200" dirty="0"/>
+            <a:endParaRPr lang="en-US" sz="2400" dirty="0"/>
           </a:p>
         </p:txBody>
       </p:sp>
@@ -5086,31 +5086,31 @@
         </p:nvSpPr>
         <p:spPr>
           <a:xfrm>
-            <a:off x="6507328" y="3977640"/>
-            <a:ext cx="2110664" cy="320040"/>
-          </a:xfrm>
-          <a:prstGeom prst="rect">
-            <a:avLst/>
-          </a:prstGeom>
-          <a:noFill/>
-          <a:ln/>
-        </p:spPr>
-        <p:txBody>
-          <a:bodyPr wrap="square" lIns="0" tIns="0" rIns="0" bIns="0" rtlCol="0" anchor="ctr"/>
+            <a:off x="5306446" y="3703320"/>
+            <a:ext cx="1624523" cy="822960"/>
+          </a:xfrm>
+          <a:prstGeom prst="rect">
+            <a:avLst/>
+          </a:prstGeom>
+          <a:noFill/>
+          <a:ln/>
+        </p:spPr>
+        <p:txBody>
+          <a:bodyPr wrap="square" lIns="0" tIns="0" rIns="0" bIns="0" rtlCol="0" anchor="t"/>
           <a:lstStyle/>
           <a:p>
             <a:pPr indent="0" marL="0">
               <a:buNone/>
             </a:pPr>
             <a:r>
-              <a:rPr lang="en-US" sz="1500" dirty="0">
+              <a:rPr lang="en-US" sz="1400" dirty="0">
                 <a:solidFill>
                   <a:srgbClr val="5B4F70"/>
                 </a:solidFill>
               </a:rPr>
               <a:t>recebíveis contratados</a:t>
             </a:r>
-            <a:endParaRPr lang="en-US" sz="1500" dirty="0"/>
+            <a:endParaRPr lang="en-US" sz="1400" dirty="0"/>
           </a:p>
         </p:txBody>
       </p:sp>
@@ -5122,12 +5122,12 @@
         </p:nvSpPr>
         <p:spPr>
           <a:xfrm>
-            <a:off x="9075191" y="2103120"/>
-            <a:ext cx="2567864" cy="2377440"/>
+            <a:off x="7342449" y="2103120"/>
+            <a:ext cx="2036003" cy="2560320"/>
           </a:xfrm>
           <a:prstGeom prst="roundRect">
             <a:avLst>
-              <a:gd name="adj" fmla="val 5769"/>
+              <a:gd name="adj" fmla="val 6737"/>
             </a:avLst>
           </a:prstGeom>
           <a:solidFill>
@@ -5144,8 +5144,8 @@
         </p:nvSpPr>
         <p:spPr>
           <a:xfrm>
-            <a:off x="9349511" y="2377440"/>
-            <a:ext cx="685800" cy="685800"/>
+            <a:off x="7571049" y="2331720"/>
+            <a:ext cx="640080" cy="640080"/>
           </a:xfrm>
           <a:prstGeom prst="ellipse">
             <a:avLst/>
@@ -5172,8 +5172,8 @@
         </p:blipFill>
         <p:spPr>
           <a:xfrm>
-            <a:off x="9520961" y="2548890"/>
-            <a:ext cx="342900" cy="342900"/>
+            <a:off x="7731069" y="2491740"/>
+            <a:ext cx="320040" cy="320040"/>
           </a:xfrm>
           <a:prstGeom prst="rect">
             <a:avLst/>
@@ -5188,8 +5188,8 @@
         </p:nvSpPr>
         <p:spPr>
           <a:xfrm>
-            <a:off x="9349511" y="3246120"/>
-            <a:ext cx="2202104" cy="731520"/>
+            <a:off x="7571049" y="3108960"/>
+            <a:ext cx="1715963" cy="548640"/>
           </a:xfrm>
           <a:prstGeom prst="rect">
             <a:avLst/>
@@ -5205,7 +5205,7 @@
               <a:buNone/>
             </a:pPr>
             <a:r>
-              <a:rPr lang="en-US" sz="3200" b="1" dirty="0">
+              <a:rPr lang="en-US" sz="2400" b="1" dirty="0">
                 <a:solidFill>
                   <a:schemeClr val="tx2"/>
                 </a:solidFill>
@@ -5215,7 +5215,7 @@
               </a:rPr>
               <a:t>0%</a:t>
             </a:r>
-            <a:endParaRPr lang="en-US" sz="3200" dirty="0"/>
+            <a:endParaRPr lang="en-US" sz="2400" dirty="0"/>
           </a:p>
         </p:txBody>
       </p:sp>
@@ -5227,48 +5227,196 @@
         </p:nvSpPr>
         <p:spPr>
           <a:xfrm>
-            <a:off x="9349511" y="3977640"/>
-            <a:ext cx="2110664" cy="320040"/>
-          </a:xfrm>
-          <a:prstGeom prst="rect">
-            <a:avLst/>
-          </a:prstGeom>
-          <a:noFill/>
-          <a:ln/>
-        </p:spPr>
-        <p:txBody>
-          <a:bodyPr wrap="square" lIns="0" tIns="0" rIns="0" bIns="0" rtlCol="0" anchor="ctr"/>
+            <a:off x="7571049" y="3703320"/>
+            <a:ext cx="1624523" cy="822960"/>
+          </a:xfrm>
+          <a:prstGeom prst="rect">
+            <a:avLst/>
+          </a:prstGeom>
+          <a:noFill/>
+          <a:ln/>
+        </p:spPr>
+        <p:txBody>
+          <a:bodyPr wrap="square" lIns="0" tIns="0" rIns="0" bIns="0" rtlCol="0" anchor="t"/>
           <a:lstStyle/>
           <a:p>
             <a:pPr indent="0" marL="0">
               <a:buNone/>
             </a:pPr>
             <a:r>
-              <a:rPr lang="en-US" sz="1500" dirty="0">
+              <a:rPr lang="en-US" sz="1400" dirty="0">
                 <a:solidFill>
                   <a:srgbClr val="5B4F70"/>
                 </a:solidFill>
               </a:rPr>
               <a:t>inadimplência</a:t>
             </a:r>
-            <a:endParaRPr lang="en-US" sz="1500" dirty="0"/>
-          </a:p>
-        </p:txBody>
-      </p:sp>
-      <p:sp>
-        <p:nvSpPr>
-          <p:cNvPr id="26" name="callout"/>
+            <a:endParaRPr lang="en-US" sz="1400" dirty="0"/>
+          </a:p>
+        </p:txBody>
+      </p:sp>
+      <p:sp>
+        <p:nvSpPr>
+          <p:cNvPr id="26" name="stat-card-4"/>
           <p:cNvSpPr/>
           <p:nvPr/>
         </p:nvSpPr>
         <p:spPr>
           <a:xfrm>
-            <a:off x="548640" y="4846320"/>
-            <a:ext cx="11094415" cy="1097280"/>
+            <a:off x="9607052" y="2103120"/>
+            <a:ext cx="2036003" cy="2560320"/>
           </a:xfrm>
           <a:prstGeom prst="roundRect">
             <a:avLst>
-              <a:gd name="adj" fmla="val 12500"/>
+              <a:gd name="adj" fmla="val 6737"/>
+            </a:avLst>
+          </a:prstGeom>
+          <a:solidFill>
+            <a:schemeClr val="accent1"/>
+          </a:solidFill>
+          <a:ln/>
+          <a:effectLst>
+            <a:outerShdw sx="100000" sy="100000" kx="0" ky="0" algn="bl" rotWithShape="0" blurRad="152400" dist="38100" dir="5400000">
+              <a:srgbClr val="2A0F52">
+                <a:alpha val="12000"/>
+              </a:srgbClr>
+            </a:outerShdw>
+          </a:effectLst>
+        </p:spPr>
+      </p:sp>
+      <p:sp>
+        <p:nvSpPr>
+          <p:cNvPr id="27" name="icon-circle-FaCoins"/>
+          <p:cNvSpPr/>
+          <p:nvPr/>
+        </p:nvSpPr>
+        <p:spPr>
+          <a:xfrm>
+            <a:off x="9835652" y="2331720"/>
+            <a:ext cx="640080" cy="640080"/>
+          </a:xfrm>
+          <a:prstGeom prst="ellipse">
+            <a:avLst/>
+          </a:prstGeom>
+          <a:solidFill>
+            <a:schemeClr val="bg1"/>
+          </a:solidFill>
+          <a:ln/>
+        </p:spPr>
+      </p:sp>
+      <p:pic>
+        <p:nvPicPr>
+          <p:cNvPr id="28" name="Image 4" descr="FaCoins">    </p:cNvPr>
+          <p:cNvPicPr>
+            <a:picLocks noChangeAspect="1"/>
+          </p:cNvPicPr>
+          <p:nvPr/>
+        </p:nvPicPr>
+        <p:blipFill>
+          <a:blip r:embed="rId5"/>
+          <a:stretch>
+            <a:fillRect/>
+          </a:stretch>
+        </p:blipFill>
+        <p:spPr>
+          <a:xfrm>
+            <a:off x="9995672" y="2491740"/>
+            <a:ext cx="320040" cy="320040"/>
+          </a:xfrm>
+          <a:prstGeom prst="rect">
+            <a:avLst/>
+          </a:prstGeom>
+        </p:spPr>
+      </p:pic>
+      <p:sp>
+        <p:nvSpPr>
+          <p:cNvPr id="29" name="Text 21"/>
+          <p:cNvSpPr txBox="1"/>
+          <p:nvPr/>
+        </p:nvSpPr>
+        <p:spPr>
+          <a:xfrm>
+            <a:off x="9835652" y="3108960"/>
+            <a:ext cx="1715963" cy="548640"/>
+          </a:xfrm>
+          <a:prstGeom prst="rect">
+            <a:avLst/>
+          </a:prstGeom>
+          <a:noFill/>
+          <a:ln/>
+        </p:spPr>
+        <p:txBody>
+          <a:bodyPr wrap="square" lIns="0" tIns="0" rIns="0" bIns="0" rtlCol="0" anchor="ctr"/>
+          <a:lstStyle/>
+          <a:p>
+            <a:pPr indent="0" marL="0">
+              <a:buNone/>
+            </a:pPr>
+            <a:r>
+              <a:rPr lang="en-US" sz="2400" b="1" dirty="0">
+                <a:solidFill>
+                  <a:schemeClr val="bg1"/>
+                </a:solidFill>
+                <a:latin typeface="Arial" pitchFamily="34" charset="0"/>
+                <a:ea typeface="Arial" pitchFamily="34" charset="-122"/>
+                <a:cs typeface="Arial" pitchFamily="34" charset="-120"/>
+              </a:rPr>
+              <a:t>R$ 100 mil</a:t>
+            </a:r>
+            <a:endParaRPr lang="en-US" sz="2400" dirty="0"/>
+          </a:p>
+        </p:txBody>
+      </p:sp>
+      <p:sp>
+        <p:nvSpPr>
+          <p:cNvPr id="30" name="Text 22"/>
+          <p:cNvSpPr txBox="1"/>
+          <p:nvPr/>
+        </p:nvSpPr>
+        <p:spPr>
+          <a:xfrm>
+            <a:off x="9835652" y="3703320"/>
+            <a:ext cx="1624523" cy="822960"/>
+          </a:xfrm>
+          <a:prstGeom prst="rect">
+            <a:avLst/>
+          </a:prstGeom>
+          <a:noFill/>
+          <a:ln/>
+        </p:spPr>
+        <p:txBody>
+          <a:bodyPr wrap="square" lIns="0" tIns="0" rIns="0" bIns="0" rtlCol="0" anchor="t"/>
+          <a:lstStyle/>
+          <a:p>
+            <a:pPr indent="0" marL="0">
+              <a:buNone/>
+            </a:pPr>
+            <a:r>
+              <a:rPr lang="en-US" sz="1400" dirty="0">
+                <a:solidFill>
+                  <a:schemeClr val="bg1"/>
+                </a:solidFill>
+              </a:rPr>
+              <a:t>dividendos pagos aos investidores em 12 meses</a:t>
+            </a:r>
+            <a:endParaRPr lang="en-US" sz="1400" dirty="0"/>
+          </a:p>
+        </p:txBody>
+      </p:sp>
+      <p:sp>
+        <p:nvSpPr>
+          <p:cNvPr id="31" name="callout"/>
+          <p:cNvSpPr/>
+          <p:nvPr/>
+        </p:nvSpPr>
+        <p:spPr>
+          <a:xfrm>
+            <a:off x="548640" y="4983480"/>
+            <a:ext cx="11094415" cy="1005840"/>
+          </a:xfrm>
+          <a:prstGeom prst="roundRect">
+            <a:avLst>
+              <a:gd name="adj" fmla="val 13636"/>
             </a:avLst>
           </a:prstGeom>
           <a:solidFill>
@@ -5279,14 +5427,14 @@
       </p:sp>
       <p:sp>
         <p:nvSpPr>
-          <p:cNvPr id="27" name="Text 20"/>
-          <p:cNvSpPr txBox="1"/>
-          <p:nvPr/>
-        </p:nvSpPr>
-        <p:spPr>
-          <a:xfrm>
-            <a:off x="914400" y="4846320"/>
-            <a:ext cx="2743200" cy="1097280"/>
+          <p:cNvPr id="32" name="Text 24"/>
+          <p:cNvSpPr txBox="1"/>
+          <p:nvPr/>
+        </p:nvSpPr>
+        <p:spPr>
+          <a:xfrm>
+            <a:off x="914400" y="4983480"/>
+            <a:ext cx="2743200" cy="1005840"/>
           </a:xfrm>
           <a:prstGeom prst="rect">
             <a:avLst/>
@@ -5315,14 +5463,14 @@
       </p:sp>
       <p:sp>
         <p:nvSpPr>
-          <p:cNvPr id="28" name="Text 21"/>
-          <p:cNvSpPr txBox="1"/>
-          <p:nvPr/>
-        </p:nvSpPr>
-        <p:spPr>
-          <a:xfrm>
-            <a:off x="3749040" y="4846320"/>
-            <a:ext cx="7589520" cy="1097280"/>
+          <p:cNvPr id="33" name="Text 25"/>
+          <p:cNvSpPr txBox="1"/>
+          <p:nvPr/>
+        </p:nvSpPr>
+        <p:spPr>
+          <a:xfrm>
+            <a:off x="3749040" y="4983480"/>
+            <a:ext cx="7589520" cy="1005840"/>
           </a:xfrm>
           <a:prstGeom prst="rect">
             <a:avLst/>

</xml_diff>

<commit_message>
Adiciona vídeo para investidores (Trustt/SCP) e roteiro de narração; gráfico com vírgula decimal
Co-Authored-By: Claude Opus 5.5 <noreply@anthropic.com>
Claude-Session: https://claude.ai/code/session_01Kg8HJBfGo9nn3yWWi5ce7m
</commit_message>
<xml_diff>
--- a/docs/ZeroInvest_Apresentacao_Investidores.pptx
+++ b/docs/ZeroInvest_Apresentacao_Investidores.pptx
@@ -117,33 +117,33 @@
   <p:extLst>
     <p:ext uri="{521415D9-36F7-43E2-AB2F-B90AF26B5E84}">
       <p14:sectionLst xmlns:p14="http://schemas.microsoft.com/office/powerpoint/2010/main">
-        <p14:section name="Abertura" id="{090b2835-78ec-639f-6740-d3d278cc3403}">
+        <p14:section name="Abertura" id="{f76a60d3-04a1-48d0-d6d2-f320a2002dec}">
           <p14:sldIdLst>
             <p14:sldId id="256"/>
           </p14:sldIdLst>
         </p14:section>
-        <p14:section name="Tese" id="{b7105860-1d14-e55e-7f3b-c759883dd2e0}">
+        <p14:section name="Tese" id="{7b9111da-49ae-fbaa-9ff2-3690b0acbdc6}">
           <p14:sldIdLst>
             <p14:sldId id="257"/>
             <p14:sldId id="258"/>
             <p14:sldId id="259"/>
           </p14:sldIdLst>
         </p14:section>
-        <p14:section name="Estrutura" id="{3cef878d-3b11-d803-ceca-e36668f44047}">
+        <p14:section name="Estrutura" id="{97d345c4-0e25-899d-3b64-78a2c75d3bc5}">
           <p14:sldIdLst>
             <p14:sldId id="260"/>
             <p14:sldId id="261"/>
             <p14:sldId id="262"/>
           </p14:sldIdLst>
         </p14:section>
-        <p14:section name="Escala" id="{3ea90813-b0f5-e5a7-5040-a0e51e3f1646}">
+        <p14:section name="Escala" id="{cfbbb9ed-0d3b-9b12-76da-baa9b6f7ad5f}">
           <p14:sldIdLst>
             <p14:sldId id="263"/>
             <p14:sldId id="264"/>
             <p14:sldId id="265"/>
           </p14:sldIdLst>
         </p14:section>
-        <p14:section name="Próximos passos" id="{a6b32c81-482f-cac6-2be6-04fbb083ab16}">
+        <p14:section name="Próximos passos" id="{e5e37160-73b3-ffba-1736-bef9ed654f87}">
           <p14:sldIdLst>
             <p14:sldId id="266"/>
           </p14:sldIdLst>
@@ -220,7 +220,7 @@
           </c:spPr>
           <c:invertIfNegative val="0"/>
           <c:dLbls>
-            <c:numFmt formatCode="&quot;R$ &quot;0.0&quot; mi&quot;" sourceLinked="0"/>
+            <c:numFmt formatCode="&quot;R$ &quot;0&quot;,&quot;0&quot; mi&quot;" sourceLinked="0"/>
             <c:txPr>
               <a:bodyPr/>
               <a:lstStyle/>
@@ -302,20 +302,20 @@
                 <c:formatCode>General</c:formatCode>
                 <c:ptCount val="3"/>
                 <c:pt idx="0">
-                  <c:v>9.1</c:v>
+                  <c:v>91</c:v>
                 </c:pt>
                 <c:pt idx="1">
-                  <c:v>27.3</c:v>
+                  <c:v>273</c:v>
                 </c:pt>
                 <c:pt idx="2">
-                  <c:v>45.4</c:v>
+                  <c:v>454</c:v>
                 </c:pt>
               </c:numCache>
             </c:numRef>
           </c:val>
         </c:ser>
         <c:dLbls>
-          <c:numFmt formatCode="&quot;R$ &quot;0.0&quot; mi&quot;" sourceLinked="0"/>
+          <c:numFmt formatCode="&quot;R$ &quot;0&quot;,&quot;0&quot; mi&quot;" sourceLinked="0"/>
           <c:txPr>
             <a:bodyPr/>
             <a:lstStyle/>
@@ -387,7 +387,7 @@
         <c:axId val="2094734552"/>
         <c:scaling>
           <c:orientation val="minMax"/>
-          <c:max val="52"/>
+          <c:max val="520"/>
           <c:min val="0"/>
         </c:scaling>
         <c:delete val="1"/>

</xml_diff>